<commit_message>
docs(slides): slide 6 links to the GitHub repo, the live prototype and the validation report
</commit_message>
<xml_diff>
--- a/output/slides/slide6/SLIDE6_with_links.pptx
+++ b/output/slides/slide6/SLIDE6_with_links.pptx
@@ -4904,14 +4904,14 @@
       </p:sp>
       <p:sp>
         <p:nvSpPr>
-          <p:cNvPr id="912" name="Link: PinPoint flight01"/>
+          <p:cNvPr id="912" name="Link: DRISHTI-3D"/>
           <p:cNvSpPr txBox="1"/>
           <p:nvPr/>
         </p:nvSpPr>
         <p:spPr>
           <a:xfrm>
-            <a:off x="941832" y="4727448"/>
-            <a:ext cx="3145536" cy="219456"/>
+            <a:off x="10129889" y="3557016"/>
+            <a:ext cx="1722397" cy="210312"/>
           </a:xfrm>
           <a:prstGeom prst="rect">
             <a:avLst/>
@@ -4924,11 +4924,11 @@
           </a:bodyPr>
           <a:lstStyle/>
           <a:p>
-            <a:pPr algn="l"/>
+            <a:pPr algn="ctr"/>
             <a:r>
               <a:rPr lang="en-US" sz="1400" b="1" u="sng" dirty="0">
                 <a:solidFill>
-                  <a:srgbClr val="0563C1"/>
+                  <a:srgbClr val="B05400"/>
                 </a:solidFill>
                 <a:latin typeface="Arial"/>
                 <a:cs typeface="Arial"/>
@@ -4940,20 +4940,20 @@
                   </a:extLst>
                 </a:hlinkClick>
               </a:rPr>
-              <a:t>PinPoint flight01</a:t>
-            </a:r>
-          </a:p>
-        </p:txBody>
-      </p:sp>
-      <p:sp>
-        <p:nvSpPr>
-          <p:cNvPr id="913" name="Link: IGN PNOA ortho + DEM"/>
+              <a:t>DRISHTI-3D</a:t>
+            </a:r>
+          </a:p>
+        </p:txBody>
+      </p:sp>
+      <p:sp>
+        <p:nvSpPr>
+          <p:cNvPr id="913" name="Link: PinPoint flight01 + 02"/>
           <p:cNvSpPr txBox="1"/>
           <p:nvPr/>
         </p:nvSpPr>
         <p:spPr>
           <a:xfrm>
-            <a:off x="941832" y="5230368"/>
+            <a:off x="941832" y="4727448"/>
             <a:ext cx="3145536" cy="219456"/>
           </a:xfrm>
           <a:prstGeom prst="rect">
@@ -4983,7 +4983,222 @@
                   </a:extLst>
                 </a:hlinkClick>
               </a:rPr>
-              <a:t>IGN PNOA ortho + DEM</a:t>
+              <a:t>PinPoint flight01 + 02</a:t>
+            </a:r>
+          </a:p>
+        </p:txBody>
+      </p:sp>
+      <p:sp>
+        <p:nvSpPr>
+          <p:cNvPr id="914" name="Link: IGN ortho + LiDAR DTM"/>
+          <p:cNvSpPr txBox="1"/>
+          <p:nvPr/>
+        </p:nvSpPr>
+        <p:spPr>
+          <a:xfrm>
+            <a:off x="941832" y="5230368"/>
+            <a:ext cx="3145536" cy="219456"/>
+          </a:xfrm>
+          <a:prstGeom prst="rect">
+            <a:avLst/>
+          </a:prstGeom>
+          <a:noFill/>
+        </p:spPr>
+        <p:txBody>
+          <a:bodyPr wrap="none" lIns="0" tIns="0" rIns="0" bIns="0" anchor="ctr" rtlCol="0">
+            <a:noAutofit/>
+          </a:bodyPr>
+          <a:lstStyle/>
+          <a:p>
+            <a:pPr algn="l"/>
+            <a:r>
+              <a:rPr lang="en-US" sz="1400" b="1" u="sng" dirty="0">
+                <a:solidFill>
+                  <a:srgbClr val="0563C1"/>
+                </a:solidFill>
+                <a:latin typeface="Arial"/>
+                <a:cs typeface="Arial"/>
+                <a:hlinkClick r:id="rId19">
+                  <a:extLst>
+                    <a:ext uri="{A12FA001-AC4F-418D-AE19-62706E023703}">
+                      <ahyp:hlinkClr xmlns:ahyp="http://schemas.microsoft.com/office/drawing/2018/hyperlinkcolor" val="tx"/>
+                    </a:ext>
+                  </a:extLst>
+                </a:hlinkClick>
+              </a:rPr>
+              <a:t>IGN ortho + LiDAR DTM</a:t>
+            </a:r>
+          </a:p>
+        </p:txBody>
+      </p:sp>
+      <p:sp>
+        <p:nvSpPr>
+          <p:cNvPr id="915" name="Link: Real-flight validation"/>
+          <p:cNvSpPr txBox="1"/>
+          <p:nvPr/>
+        </p:nvSpPr>
+        <p:spPr>
+          <a:xfrm>
+            <a:off x="4782312" y="4727448"/>
+            <a:ext cx="3145536" cy="219456"/>
+          </a:xfrm>
+          <a:prstGeom prst="rect">
+            <a:avLst/>
+          </a:prstGeom>
+          <a:noFill/>
+        </p:spPr>
+        <p:txBody>
+          <a:bodyPr wrap="none" lIns="0" tIns="0" rIns="0" bIns="0" anchor="ctr" rtlCol="0">
+            <a:noAutofit/>
+          </a:bodyPr>
+          <a:lstStyle/>
+          <a:p>
+            <a:pPr algn="l"/>
+            <a:r>
+              <a:rPr lang="en-US" sz="1400" b="1" u="sng" dirty="0">
+                <a:solidFill>
+                  <a:srgbClr val="0563C1"/>
+                </a:solidFill>
+                <a:latin typeface="Arial"/>
+                <a:cs typeface="Arial"/>
+                <a:hlinkClick r:id="rId20">
+                  <a:extLst>
+                    <a:ext uri="{A12FA001-AC4F-418D-AE19-62706E023703}">
+                      <ahyp:hlinkClr xmlns:ahyp="http://schemas.microsoft.com/office/drawing/2018/hyperlinkcolor" val="tx"/>
+                    </a:ext>
+                  </a:extLst>
+                </a:hlinkClick>
+              </a:rPr>
+              <a:t>Real-flight validation</a:t>
+            </a:r>
+          </a:p>
+        </p:txBody>
+      </p:sp>
+      <p:sp>
+        <p:nvSpPr>
+          <p:cNvPr id="916" name="Link: COLMAP, same frames"/>
+          <p:cNvSpPr txBox="1"/>
+          <p:nvPr/>
+        </p:nvSpPr>
+        <p:spPr>
+          <a:xfrm>
+            <a:off x="4782312" y="5230368"/>
+            <a:ext cx="3145536" cy="219456"/>
+          </a:xfrm>
+          <a:prstGeom prst="rect">
+            <a:avLst/>
+          </a:prstGeom>
+          <a:noFill/>
+        </p:spPr>
+        <p:txBody>
+          <a:bodyPr wrap="none" lIns="0" tIns="0" rIns="0" bIns="0" anchor="ctr" rtlCol="0">
+            <a:noAutofit/>
+          </a:bodyPr>
+          <a:lstStyle/>
+          <a:p>
+            <a:pPr algn="l"/>
+            <a:r>
+              <a:rPr lang="en-US" sz="1400" b="1" u="sng" dirty="0">
+                <a:solidFill>
+                  <a:srgbClr val="0563C1"/>
+                </a:solidFill>
+                <a:latin typeface="Arial"/>
+                <a:cs typeface="Arial"/>
+                <a:hlinkClick r:id="rId21">
+                  <a:extLst>
+                    <a:ext uri="{A12FA001-AC4F-418D-AE19-62706E023703}">
+                      <ahyp:hlinkClr xmlns:ahyp="http://schemas.microsoft.com/office/drawing/2018/hyperlinkcolor" val="tx"/>
+                    </a:ext>
+                  </a:extLst>
+                </a:hlinkClick>
+              </a:rPr>
+              <a:t>COLMAP, same frames</a:t>
+            </a:r>
+          </a:p>
+        </p:txBody>
+      </p:sp>
+      <p:sp>
+        <p:nvSpPr>
+          <p:cNvPr id="917" name="Link: github.com/Ajith-Praveen/Drishti-3D"/>
+          <p:cNvSpPr txBox="1"/>
+          <p:nvPr/>
+        </p:nvSpPr>
+        <p:spPr>
+          <a:xfrm>
+            <a:off x="8750808" y="4992624"/>
+            <a:ext cx="2898648" cy="237744"/>
+          </a:xfrm>
+          <a:prstGeom prst="rect">
+            <a:avLst/>
+          </a:prstGeom>
+          <a:noFill/>
+        </p:spPr>
+        <p:txBody>
+          <a:bodyPr wrap="none" lIns="0" tIns="0" rIns="0" bIns="0" anchor="ctr" rtlCol="0">
+            <a:noAutofit/>
+          </a:bodyPr>
+          <a:lstStyle/>
+          <a:p>
+            <a:pPr algn="l"/>
+            <a:r>
+              <a:rPr lang="en-US" sz="1400" u="sng" dirty="0">
+                <a:solidFill>
+                  <a:srgbClr val="0563C1"/>
+                </a:solidFill>
+                <a:latin typeface="Arial"/>
+                <a:cs typeface="Arial"/>
+                <a:hlinkClick r:id="rId22">
+                  <a:extLst>
+                    <a:ext uri="{A12FA001-AC4F-418D-AE19-62706E023703}">
+                      <ahyp:hlinkClr xmlns:ahyp="http://schemas.microsoft.com/office/drawing/2018/hyperlinkcolor" val="tx"/>
+                    </a:ext>
+                  </a:extLst>
+                </a:hlinkClick>
+              </a:rPr>
+              <a:t>github.com/Ajith-Praveen/Drishti-3D</a:t>
+            </a:r>
+          </a:p>
+        </p:txBody>
+      </p:sp>
+      <p:sp>
+        <p:nvSpPr>
+          <p:cNvPr id="918" name="Link: 13-234-83-238.sslip.io"/>
+          <p:cNvSpPr txBox="1"/>
+          <p:nvPr/>
+        </p:nvSpPr>
+        <p:spPr>
+          <a:xfrm>
+            <a:off x="8750808" y="5779008"/>
+            <a:ext cx="2898648" cy="237744"/>
+          </a:xfrm>
+          <a:prstGeom prst="rect">
+            <a:avLst/>
+          </a:prstGeom>
+          <a:noFill/>
+        </p:spPr>
+        <p:txBody>
+          <a:bodyPr wrap="none" lIns="0" tIns="0" rIns="0" bIns="0" anchor="ctr" rtlCol="0">
+            <a:noAutofit/>
+          </a:bodyPr>
+          <a:lstStyle/>
+          <a:p>
+            <a:pPr algn="l"/>
+            <a:r>
+              <a:rPr lang="en-US" sz="1400" u="sng" dirty="0">
+                <a:solidFill>
+                  <a:srgbClr val="0563C1"/>
+                </a:solidFill>
+                <a:latin typeface="Arial"/>
+                <a:cs typeface="Arial"/>
+                <a:hlinkClick r:id="rId23">
+                  <a:extLst>
+                    <a:ext uri="{A12FA001-AC4F-418D-AE19-62706E023703}">
+                      <ahyp:hlinkClr xmlns:ahyp="http://schemas.microsoft.com/office/drawing/2018/hyperlinkcolor" val="tx"/>
+                    </a:ext>
+                  </a:extLst>
+                </a:hlinkClick>
+              </a:rPr>
+              <a:t>13-234-83-238.sslip.io</a:t>
             </a:r>
           </a:p>
         </p:txBody>

</xml_diff>